<commit_message>
feat: legal pre-avocat, live theater UX, docs juridique et deploy assets
- Pages legal (communauté, pub, DSA, copyright) + CGU v2026-08-03
- Live/salon theater layout et chat flottant (web + apptel)
- Backend legal sync, geo/groups/native push; dossier docs réorganisé
- Cursor Cloud config, sponsor commercial docs, build public assets

Co-authored-by: Cursor <cursoragent@cursor.com>
</commit_message>
<xml_diff>
--- a/commun/docs/strategie/SOUNDY-PRESENTATION-PRODUIT.pptx
+++ b/commun/docs/strategie/SOUNDY-PRESENTATION-PRODUIT.pptx
@@ -2128,7 +2128,7 @@
                 <a:ea typeface="Calibri" pitchFamily="34" charset="-122"/>
                 <a:cs typeface="Calibri" pitchFamily="34" charset="-120"/>
               </a:rPr>
-              <a:t>REELS</a:t>
+              <a:t>BUSINESS</a:t>
             </a:r>
             <a:endParaRPr lang="en-US" sz="800" dirty="0"/>
           </a:p>
@@ -2167,7 +2167,7 @@
                 <a:ea typeface="Calibri" pitchFamily="34" charset="-122"/>
                 <a:cs typeface="Calibri" pitchFamily="34" charset="-120"/>
               </a:rPr>
-              <a:t>Reels artistiques</a:t>
+              <a:t>Comment Soundy est rémunéré</a:t>
             </a:r>
             <a:endParaRPr lang="en-US" sz="2000" dirty="0"/>
           </a:p>
@@ -2206,7 +2206,7 @@
                 <a:ea typeface="Calibri" pitchFamily="34" charset="-122"/>
                 <a:cs typeface="Calibri" pitchFamily="34" charset="-120"/>
               </a:rPr>
-              <a:t>Format 9:16 — promotion musicale uniquement.</a:t>
+              <a:t>Leviers alignés avec l'usage — sans pub intrusive.</a:t>
             </a:r>
             <a:endParaRPr lang="en-US" sz="900" dirty="0"/>
           </a:p>
@@ -2249,7 +2249,7 @@
                 <a:ea typeface="Calibri" pitchFamily="34" charset="-122"/>
                 <a:cs typeface="Calibri" pitchFamily="34" charset="-120"/>
               </a:rPr>
-              <a:t>Teasers DJ set, aftermovies, extraits live</a:t>
+              <a:t>Sponsoring natif — bars, festivals, marques (sur devis)</a:t>
             </a:r>
             <a:endParaRPr lang="en-US" sz="900" dirty="0"/>
           </a:p>
@@ -2270,7 +2270,7 @@
                 <a:ea typeface="Calibri" pitchFamily="34" charset="-122"/>
                 <a:cs typeface="Calibri" pitchFamily="34" charset="-120"/>
               </a:rPr>
-              <a:t>Présentation album, single ou EP</a:t>
+              <a:t>Pourboires créateurs pendant les lives</a:t>
             </a:r>
             <a:endParaRPr lang="en-US" sz="900" dirty="0"/>
           </a:p>
@@ -2291,7 +2291,7 @@
                 <a:ea typeface="Calibri" pitchFamily="34" charset="-122"/>
                 <a:cs typeface="Calibri" pitchFamily="34" charset="-120"/>
               </a:rPr>
-              <a:t>Annonce événement ou date de tournée</a:t>
+              <a:t>Abonnements Supporter / Super fan</a:t>
             </a:r>
             <a:endParaRPr lang="en-US" sz="900" dirty="0"/>
           </a:p>
@@ -2312,7 +2312,7 @@
                 <a:ea typeface="Calibri" pitchFamily="34" charset="-122"/>
                 <a:cs typeface="Calibri" pitchFamily="34" charset="-120"/>
               </a:rPr>
-              <a:t>Reels sponsorisés lieux &amp; labels</a:t>
+              <a:t>Offres lieux partenaires (à venir)</a:t>
             </a:r>
             <a:endParaRPr lang="en-US" sz="900" dirty="0"/>
           </a:p>
@@ -2378,7 +2378,7 @@
                 <a:ea typeface="Calibri" pitchFamily="34" charset="-122"/>
                 <a:cs typeface="Calibri" pitchFamily="34" charset="-120"/>
               </a:rPr>
-              <a:t>Chaque Reel sert la visibilité d'un artiste ou d'un événement.</a:t>
+              <a:t>Grille sur devis · estimation d'audience avant campagne.</a:t>
             </a:r>
             <a:endParaRPr lang="en-US" sz="850" dirty="0"/>
           </a:p>
@@ -2413,7 +2413,7 @@
       </p:sp>
       <p:pic>
         <p:nvPicPr>
-          <p:cNvPr id="10" name="Image 0" descr="C:\Dev\Soundy\commun\docs\presentation-screenshots\mobile\12-reels.png">    </p:cNvPr>
+          <p:cNvPr id="10" name="Image 0" descr="C:\Dev\Soundy\commun\docs\presentation-screenshots\mobile\08-profil.png">    </p:cNvPr>
           <p:cNvPicPr>
             <a:picLocks noChangeAspect="1"/>
           </p:cNvPicPr>
@@ -2467,7 +2467,7 @@
                 <a:ea typeface="Calibri" pitchFamily="34" charset="-122"/>
                 <a:cs typeface="Calibri" pitchFamily="34" charset="-120"/>
               </a:rPr>
-              <a:t>Reels · artistique</a:t>
+              <a:t>Créateurs &amp; lieux</a:t>
             </a:r>
             <a:endParaRPr lang="en-US" sz="700" dirty="0"/>
           </a:p>
@@ -3511,7 +3511,7 @@
                 <a:ea typeface="Calibri" pitchFamily="34" charset="-122"/>
                 <a:cs typeface="Calibri" pitchFamily="34" charset="-120"/>
               </a:rPr>
-              <a:t>Modèle économique</a:t>
+              <a:t>Reels artistiques</a:t>
             </a:r>
             <a:endParaRPr lang="en-US" sz="1100" dirty="0"/>
           </a:p>
@@ -3636,7 +3636,7 @@
                 <a:ea typeface="Calibri" pitchFamily="34" charset="-122"/>
                 <a:cs typeface="Calibri" pitchFamily="34" charset="-120"/>
               </a:rPr>
-              <a:t>Reels artistiques</a:t>
+              <a:t>Modèle économique</a:t>
             </a:r>
             <a:endParaRPr lang="en-US" sz="1100" dirty="0"/>
           </a:p>
@@ -6807,7 +6807,7 @@
                 <a:ea typeface="Calibri" pitchFamily="34" charset="-122"/>
                 <a:cs typeface="Calibri" pitchFamily="34" charset="-120"/>
               </a:rPr>
-              <a:t>BUSINESS</a:t>
+              <a:t>REELS</a:t>
             </a:r>
             <a:endParaRPr lang="en-US" sz="800" dirty="0"/>
           </a:p>
@@ -6846,7 +6846,7 @@
                 <a:ea typeface="Calibri" pitchFamily="34" charset="-122"/>
                 <a:cs typeface="Calibri" pitchFamily="34" charset="-120"/>
               </a:rPr>
-              <a:t>Comment Soundy est rémunéré</a:t>
+              <a:t>Reels artistiques</a:t>
             </a:r>
             <a:endParaRPr lang="en-US" sz="2000" dirty="0"/>
           </a:p>
@@ -6885,7 +6885,7 @@
                 <a:ea typeface="Calibri" pitchFamily="34" charset="-122"/>
                 <a:cs typeface="Calibri" pitchFamily="34" charset="-120"/>
               </a:rPr>
-              <a:t>Leviers alignés avec l'usage — sans pub intrusive.</a:t>
+              <a:t>Format 9:16 — promotion musicale uniquement.</a:t>
             </a:r>
             <a:endParaRPr lang="en-US" sz="900" dirty="0"/>
           </a:p>
@@ -6928,7 +6928,7 @@
                 <a:ea typeface="Calibri" pitchFamily="34" charset="-122"/>
                 <a:cs typeface="Calibri" pitchFamily="34" charset="-120"/>
               </a:rPr>
-              <a:t>Sponsoring natif — bars, festivals, marques (sur devis)</a:t>
+              <a:t>Teasers DJ set, aftermovies, extraits live</a:t>
             </a:r>
             <a:endParaRPr lang="en-US" sz="900" dirty="0"/>
           </a:p>
@@ -6949,7 +6949,7 @@
                 <a:ea typeface="Calibri" pitchFamily="34" charset="-122"/>
                 <a:cs typeface="Calibri" pitchFamily="34" charset="-120"/>
               </a:rPr>
-              <a:t>Pourboires créateurs pendant les lives</a:t>
+              <a:t>Présentation album, single ou EP</a:t>
             </a:r>
             <a:endParaRPr lang="en-US" sz="900" dirty="0"/>
           </a:p>
@@ -6970,7 +6970,7 @@
                 <a:ea typeface="Calibri" pitchFamily="34" charset="-122"/>
                 <a:cs typeface="Calibri" pitchFamily="34" charset="-120"/>
               </a:rPr>
-              <a:t>Abonnements Supporter / Super fan</a:t>
+              <a:t>Annonce événement ou date de tournée</a:t>
             </a:r>
             <a:endParaRPr lang="en-US" sz="900" dirty="0"/>
           </a:p>
@@ -6991,7 +6991,7 @@
                 <a:ea typeface="Calibri" pitchFamily="34" charset="-122"/>
                 <a:cs typeface="Calibri" pitchFamily="34" charset="-120"/>
               </a:rPr>
-              <a:t>Offres lieux partenaires (à venir)</a:t>
+              <a:t>Reels sponsorisés lieux &amp; labels</a:t>
             </a:r>
             <a:endParaRPr lang="en-US" sz="900" dirty="0"/>
           </a:p>
@@ -7057,7 +7057,7 @@
                 <a:ea typeface="Calibri" pitchFamily="34" charset="-122"/>
                 <a:cs typeface="Calibri" pitchFamily="34" charset="-120"/>
               </a:rPr>
-              <a:t>Grille sur devis · estimation d'audience avant campagne.</a:t>
+              <a:t>Chaque Reel sert la visibilité d'un artiste ou d'un événement.</a:t>
             </a:r>
             <a:endParaRPr lang="en-US" sz="850" dirty="0"/>
           </a:p>
@@ -7092,7 +7092,7 @@
       </p:sp>
       <p:pic>
         <p:nvPicPr>
-          <p:cNvPr id="10" name="Image 0" descr="C:\Dev\Soundy\commun\docs\presentation-screenshots\mobile\08-profil.png">    </p:cNvPr>
+          <p:cNvPr id="10" name="Image 0" descr="C:\Dev\Soundy\commun\docs\presentation-screenshots\mobile\12-reels.png">    </p:cNvPr>
           <p:cNvPicPr>
             <a:picLocks noChangeAspect="1"/>
           </p:cNvPicPr>
@@ -7146,7 +7146,7 @@
                 <a:ea typeface="Calibri" pitchFamily="34" charset="-122"/>
                 <a:cs typeface="Calibri" pitchFamily="34" charset="-120"/>
               </a:rPr>
-              <a:t>Créateurs &amp; lieux</a:t>
+              <a:t>Reels · artistique</a:t>
             </a:r>
             <a:endParaRPr lang="en-US" sz="700" dirty="0"/>
           </a:p>

</xml_diff>